<commit_message>
S1-CL1: realign all 15 slide decks to the AT2/AT3 workbooks; add AT2 task 17 (shared responsibility); move PC 2.4 to compute
Co-Authored-By: Claude Fable 5 <noreply@anthropic.com>
</commit_message>
<xml_diff>
--- a/S1-CL1-Cloud-Design-Build/delivery/topic_05/Topic_05_Slides.pptx
+++ b/S1-CL1-Cloud-Design-Build/delivery/topic_05/Topic_05_Slides.pptx
@@ -569,7 +569,7 @@
           </a:p>
           <a:p>
             <a:r>
-              <a:t>Misconception to pre-empt: "the marks are all in the document." No — Part B assesses the live</a:t>
+              <a:t>Misconception to pre-empt: "it is all in the document." No — Part B assesses the live</a:t>
             </a:r>
           </a:p>
           <a:p>
@@ -854,7 +854,7 @@
           </a:p>
           <a:p>
             <a:r>
-              <a:t>deliberately tests the reasoning behind your recommendation. Under-preparing for it forfeits marks.</a:t>
+              <a:t>deliberately tests the reasoning behind your recommendation. Under-preparing for it puts a satisfactory result at risk.</a:t>
             </a:r>
           </a:p>
           <a:p>

</xml_diff>